<commit_message>
Tata Power deck: fill in student details on title slide
Co-Authored-By: Claude Opus 4.8 <noreply@anthropic.com>
Claude-Session: https://claude.ai/code/session_01Sc2NZrEuuYCA6YzzZ2iW5Z
</commit_message>
<xml_diff>
--- a/morris-worm-case-study/Tata-Power-Cyberattack-2022-Case-Study.pptx
+++ b/morris-worm-case-study/Tata-Power-Cyberattack-2022-Case-Study.pptx
@@ -2431,13 +2431,13 @@
             <a:r>
               <a:rPr lang="en-US" sz="1150" dirty="0">
                 <a:solidFill>
-                  <a:srgbClr val="94A3B8"/>
+                  <a:srgbClr val="EAF4FB"/>
                 </a:solidFill>
                 <a:latin typeface="Courier New" pitchFamily="34" charset="0"/>
                 <a:ea typeface="Courier New" pitchFamily="34" charset="-122"/>
                 <a:cs typeface="Courier New" pitchFamily="34" charset="-120"/>
               </a:rPr>
-              <a:t>______________</a:t>
+              <a:t>Avdhoot Kamthe</a:t>
             </a:r>
             <a:endParaRPr lang="en-US" sz="1150" dirty="0"/>
           </a:p>
@@ -2484,13 +2484,13 @@
             <a:r>
               <a:rPr lang="en-US" sz="1150" dirty="0">
                 <a:solidFill>
-                  <a:srgbClr val="94A3B8"/>
+                  <a:srgbClr val="EAF4FB"/>
                 </a:solidFill>
                 <a:latin typeface="Courier New" pitchFamily="34" charset="0"/>
                 <a:ea typeface="Courier New" pitchFamily="34" charset="-122"/>
                 <a:cs typeface="Courier New" pitchFamily="34" charset="-120"/>
               </a:rPr>
-              <a:t>______________</a:t>
+              <a:t>20406094</a:t>
             </a:r>
             <a:endParaRPr lang="en-US" sz="1150" dirty="0"/>
           </a:p>
@@ -2537,13 +2537,13 @@
             <a:r>
               <a:rPr lang="en-US" sz="1150" dirty="0">
                 <a:solidFill>
-                  <a:srgbClr val="94A3B8"/>
+                  <a:srgbClr val="EAF4FB"/>
                 </a:solidFill>
                 <a:latin typeface="Courier New" pitchFamily="34" charset="0"/>
                 <a:ea typeface="Courier New" pitchFamily="34" charset="-122"/>
                 <a:cs typeface="Courier New" pitchFamily="34" charset="-120"/>
               </a:rPr>
-              <a:t>______________</a:t>
+              <a:t>H3</a:t>
             </a:r>
             <a:endParaRPr lang="en-US" sz="1150" dirty="0"/>
           </a:p>
@@ -2590,13 +2590,13 @@
             <a:r>
               <a:rPr lang="en-US" sz="1150" dirty="0">
                 <a:solidFill>
-                  <a:srgbClr val="94A3B8"/>
+                  <a:srgbClr val="EAF4FB"/>
                 </a:solidFill>
                 <a:latin typeface="Courier New" pitchFamily="34" charset="0"/>
                 <a:ea typeface="Courier New" pitchFamily="34" charset="-122"/>
                 <a:cs typeface="Courier New" pitchFamily="34" charset="-120"/>
               </a:rPr>
-              <a:t>______________</a:t>
+              <a:t>Cyber Security</a:t>
             </a:r>
             <a:endParaRPr lang="en-US" sz="1150" dirty="0"/>
           </a:p>
@@ -2643,54 +2643,15 @@
             <a:r>
               <a:rPr lang="en-US" sz="1150" dirty="0">
                 <a:solidFill>
-                  <a:srgbClr val="94A3B8"/>
+                  <a:srgbClr val="EAF4FB"/>
                 </a:solidFill>
                 <a:latin typeface="Courier New" pitchFamily="34" charset="0"/>
                 <a:ea typeface="Courier New" pitchFamily="34" charset="-122"/>
                 <a:cs typeface="Courier New" pitchFamily="34" charset="-120"/>
               </a:rPr>
-              <a:t>______________</a:t>
+              <a:t>Smt. S. P. Ambavane</a:t>
             </a:r>
             <a:endParaRPr lang="en-US" sz="1150" dirty="0"/>
-          </a:p>
-        </p:txBody>
-      </p:sp>
-      <p:sp>
-        <p:nvSpPr>
-          <p:cNvPr id="19" name="Text 15"/>
-          <p:cNvSpPr txBox="1"/>
-          <p:nvPr/>
-        </p:nvSpPr>
-        <p:spPr>
-          <a:xfrm>
-            <a:off x="4114800" y="5833872"/>
-            <a:ext cx="2743200" cy="274320"/>
-          </a:xfrm>
-          <a:prstGeom prst="rect">
-            <a:avLst/>
-          </a:prstGeom>
-          <a:noFill/>
-          <a:ln/>
-        </p:spPr>
-        <p:txBody>
-          <a:bodyPr wrap="square" lIns="0" tIns="0" rIns="0" bIns="0" rtlCol="0" anchor="ctr"/>
-          <a:lstStyle/>
-          <a:p>
-            <a:pPr indent="0" marL="0">
-              <a:buNone/>
-            </a:pPr>
-            <a:r>
-              <a:rPr lang="en-US" sz="1050" i="1" dirty="0">
-                <a:solidFill>
-                  <a:srgbClr val="94A3B8"/>
-                </a:solidFill>
-                <a:latin typeface="Courier New" pitchFamily="34" charset="0"/>
-                <a:ea typeface="Courier New" pitchFamily="34" charset="-122"/>
-                <a:cs typeface="Courier New" pitchFamily="34" charset="-120"/>
-              </a:rPr>
-              <a:t>Cyber Security · Case Study</a:t>
-            </a:r>
-            <a:endParaRPr lang="en-US" sz="1050" dirty="0"/>
           </a:p>
         </p:txBody>
       </p:sp>

</xml_diff>